<commit_message>
Add Model B technical description, design precedents and formal review
Model_B_Slides.pptx follows the lab deck style: end-to-end diagram, a
27-step table covering data, windows, preprocessing, network, training
and evaluation, a precedent for every design choice, changes since the
4/22 proposal, a false-positive plan and references.
Model_B_Technical_Description.docx carries the same content in writing.
Literature_Review_Formal.docx is a narrative review in the layout of
the Frontiers ECG paper, with 38 checked references.

Corrects an earlier error: Model B's input is z-scored per window with
no frequency filter, not band-passed. The earlier review, slide and
HANDOFF.md are updated to match.

Co-Authored-By: Claude Opus 5.5 <noreply@anthropic.com>
Claude-Session: https://claude.ai/code/session_01AtTQN8juVHUnnCJVsQQ1fw
</commit_message>
<xml_diff>
--- a/literature_review/Literature_Review_Slide.pptx
+++ b/literature_review/Literature_Review_Slide.pptx
@@ -3123,7 +3123,7 @@
                           <a:ea typeface="Calibri" pitchFamily="34" charset="-122"/>
                           <a:cs typeface="Calibri" pitchFamily="34" charset="-120"/>
                         </a:rPr>
-                        <a:t>Band passed time series</a:t>
+                        <a:t>Z-scored time series</a:t>
                       </a:r>
                       <a:endParaRPr lang="en-US" sz="1300" dirty="0">
                         <a:latin typeface="Calibri" charset="0"/>
@@ -4003,7 +4003,7 @@
                 <a:ea typeface="Calibri" pitchFamily="34" charset="-122"/>
                 <a:cs typeface="Calibri" pitchFamily="34" charset="-120"/>
               </a:rPr>
-              <a:t>A compact 1D CNN on band passed four channel time series, with subject independent validation. No transformer at this data scale.</a:t>
+              <a:t>A compact 1D CNN on z-scored four channel time series, with subject independent validation. No transformer at this data scale.</a:t>
             </a:r>
             <a:endParaRPr lang="en-US" sz="1500" dirty="0"/>
           </a:p>

</xml_diff>